<commit_message>
Fix presentation assets and worksheet
</commit_message>
<xml_diff>
--- a/output/pptx/Seminar_Slides_VI_Demo.pptx
+++ b/output/pptx/Seminar_Slides_VI_Demo.pptx
@@ -2,27 +2,28 @@
 <file path=ppt/presentation.xml><?xml version="1.0" encoding="utf-8"?>
 <p:presentation xmlns:p="http://schemas.openxmlformats.org/presentationml/2006/main">
   <p:sldMasterIdLst>
-    <p:sldMasterId xmlns:r="http://schemas.openxmlformats.org/officeDocument/2006/relationships" id="2147483648" r:id="R917d81319e734a0a"/>
+    <p:sldMasterId xmlns:r="http://schemas.openxmlformats.org/officeDocument/2006/relationships" id="2147483648" r:id="Rd4359534f4a4482b"/>
   </p:sldMasterIdLst>
   <p:notesMasterIdLst>
-    <p:notesMasterId xmlns:r="http://schemas.openxmlformats.org/officeDocument/2006/relationships" r:id="Rdf9f6f5a2faa47d0"/>
+    <p:notesMasterId xmlns:r="http://schemas.openxmlformats.org/officeDocument/2006/relationships" r:id="R1a7ff57909384b31"/>
   </p:notesMasterIdLst>
   <p:sldIdLst>
-    <p:sldId xmlns:r="http://schemas.openxmlformats.org/officeDocument/2006/relationships" id="256" r:id="R764a1ec62ff14500"/>
-    <p:sldId xmlns:r="http://schemas.openxmlformats.org/officeDocument/2006/relationships" id="257" r:id="Re278f36c88904311"/>
-    <p:sldId xmlns:r="http://schemas.openxmlformats.org/officeDocument/2006/relationships" id="258" r:id="R784325c33d064bcb"/>
-    <p:sldId xmlns:r="http://schemas.openxmlformats.org/officeDocument/2006/relationships" id="259" r:id="R9294e87776494f4d"/>
-    <p:sldId xmlns:r="http://schemas.openxmlformats.org/officeDocument/2006/relationships" id="260" r:id="Rd98ccdc8fdc548df"/>
-    <p:sldId xmlns:r="http://schemas.openxmlformats.org/officeDocument/2006/relationships" id="261" r:id="R826fe65385bf4698"/>
-    <p:sldId xmlns:r="http://schemas.openxmlformats.org/officeDocument/2006/relationships" id="262" r:id="R872d04333dcf4d08"/>
-    <p:sldId xmlns:r="http://schemas.openxmlformats.org/officeDocument/2006/relationships" id="263" r:id="Ra4fbc7e5010b47ec"/>
-    <p:sldId xmlns:r="http://schemas.openxmlformats.org/officeDocument/2006/relationships" id="264" r:id="R3fffb3f4746b461b"/>
-    <p:sldId xmlns:r="http://schemas.openxmlformats.org/officeDocument/2006/relationships" id="265" r:id="R1b2ae3958ef7423f"/>
-    <p:sldId xmlns:r="http://schemas.openxmlformats.org/officeDocument/2006/relationships" id="266" r:id="R14e0893d61154109"/>
-    <p:sldId xmlns:r="http://schemas.openxmlformats.org/officeDocument/2006/relationships" id="267" r:id="R04f499613c0a4398"/>
-    <p:sldId xmlns:r="http://schemas.openxmlformats.org/officeDocument/2006/relationships" id="268" r:id="R1dd32b1a3d894f0d"/>
-    <p:sldId xmlns:r="http://schemas.openxmlformats.org/officeDocument/2006/relationships" id="269" r:id="Ra17720a291204fdf"/>
-    <p:sldId xmlns:r="http://schemas.openxmlformats.org/officeDocument/2006/relationships" id="270" r:id="R15d5fe36dc094ec3"/>
+    <p:sldId xmlns:r="http://schemas.openxmlformats.org/officeDocument/2006/relationships" id="256" r:id="R027eee7429cc4136"/>
+    <p:sldId xmlns:r="http://schemas.openxmlformats.org/officeDocument/2006/relationships" id="257" r:id="R2d34e1a5ffe54ee8"/>
+    <p:sldId xmlns:r="http://schemas.openxmlformats.org/officeDocument/2006/relationships" id="258" r:id="R410ce249475a4e20"/>
+    <p:sldId xmlns:r="http://schemas.openxmlformats.org/officeDocument/2006/relationships" id="259" r:id="R22c81d33fca540a4"/>
+    <p:sldId xmlns:r="http://schemas.openxmlformats.org/officeDocument/2006/relationships" id="260" r:id="Ra3401648e0f84678"/>
+    <p:sldId xmlns:r="http://schemas.openxmlformats.org/officeDocument/2006/relationships" id="261" r:id="R755400042c954d0a"/>
+    <p:sldId xmlns:r="http://schemas.openxmlformats.org/officeDocument/2006/relationships" id="262" r:id="Rcfc0bac319d34c3c"/>
+    <p:sldId xmlns:r="http://schemas.openxmlformats.org/officeDocument/2006/relationships" id="263" r:id="Re4e493bf3c7c43ef"/>
+    <p:sldId xmlns:r="http://schemas.openxmlformats.org/officeDocument/2006/relationships" id="264" r:id="R136b81408b234366"/>
+    <p:sldId xmlns:r="http://schemas.openxmlformats.org/officeDocument/2006/relationships" id="265" r:id="R7976b948374d44ea"/>
+    <p:sldId xmlns:r="http://schemas.openxmlformats.org/officeDocument/2006/relationships" id="266" r:id="R8b65c03f7df9421a"/>
+    <p:sldId xmlns:r="http://schemas.openxmlformats.org/officeDocument/2006/relationships" id="267" r:id="Rc74a91edf8fb463b"/>
+    <p:sldId xmlns:r="http://schemas.openxmlformats.org/officeDocument/2006/relationships" id="268" r:id="R62610d45b5ff4f8e"/>
+    <p:sldId xmlns:r="http://schemas.openxmlformats.org/officeDocument/2006/relationships" id="269" r:id="R8ac710dc7f024a2f"/>
+    <p:sldId xmlns:r="http://schemas.openxmlformats.org/officeDocument/2006/relationships" id="270" r:id="R0ce358261d9940a8"/>
+    <p:sldId xmlns:r="http://schemas.openxmlformats.org/officeDocument/2006/relationships" id="271" r:id="Ra580c3d88f7b4bf1"/>
   </p:sldIdLst>
   <p:sldSz cx="12192000" cy="6858000"/>
   <p:notesSz cx="6858000" cy="9144000"/>
@@ -1001,6 +1002,76 @@
 </p:notes>
 </file>
 
+<file path=ppt/notesSlides/notesSlide16.xml><?xml version="1.0" encoding="utf-8"?>
+<p:notes xmlns:p="http://schemas.openxmlformats.org/presentationml/2006/main">
+  <p:cSld>
+    <p:spTree>
+      <p:nvGrpSpPr>
+        <p:cNvPr id="1" name=""/>
+        <p:cNvGrpSpPr/>
+        <p:nvPr/>
+      </p:nvGrpSpPr>
+      <p:grpSpPr>
+        <a:xfrm xmlns:a="http://schemas.openxmlformats.org/drawingml/2006/main"/>
+      </p:grpSpPr>
+      <p:sp>
+        <p:nvSpPr>
+          <p:cNvPr id="2" name="Slide Image Placeholder 1"/>
+          <p:cNvSpPr>
+            <a:spLocks xmlns:a="http://schemas.openxmlformats.org/drawingml/2006/main" noGrp="1"/>
+          </p:cNvSpPr>
+          <p:nvPr>
+            <p:ph type="sldImg" idx="0"/>
+          </p:nvPr>
+        </p:nvSpPr>
+        <p:spPr/>
+      </p:sp>
+      <p:sp>
+        <p:nvSpPr>
+          <p:cNvPr id="3" name="Notes Placeholder 2"/>
+          <p:cNvSpPr>
+            <a:spLocks xmlns:a="http://schemas.openxmlformats.org/drawingml/2006/main" noGrp="1"/>
+          </p:cNvSpPr>
+          <p:nvPr>
+            <p:ph type="body" idx="1"/>
+          </p:nvPr>
+        </p:nvSpPr>
+        <p:spPr/>
+        <p:txBody>
+          <a:bodyPr xmlns:a="http://schemas.openxmlformats.org/drawingml/2006/main"/>
+          <a:lstStyle xmlns:a="http://schemas.openxmlformats.org/drawingml/2006/main"/>
+          <a:p xmlns:a="http://schemas.openxmlformats.org/drawingml/2006/main">
+            <a:r>
+              <a:t>Mời thầy và các bạn dùng điện thoại quét mã QR để mở bài test. Sau khi mọi người tham gia, nhóm bắt đầu phần câu hỏi ôn tập về database testing và ba công cụ.</a:t>
+            </a:r>
+          </a:p>
+        </p:txBody>
+      </p:sp>
+      <p:sp>
+        <p:nvSpPr>
+          <p:cNvPr id="4" name="Slide Number Placeholder 3"/>
+          <p:cNvSpPr>
+            <a:spLocks xmlns:a="http://schemas.openxmlformats.org/drawingml/2006/main" noGrp="1"/>
+          </p:cNvSpPr>
+          <p:nvPr>
+            <p:ph type="sldNum" idx="5"/>
+          </p:nvPr>
+        </p:nvSpPr>
+        <p:spPr/>
+        <p:txBody>
+          <a:bodyPr xmlns:a="http://schemas.openxmlformats.org/drawingml/2006/main"/>
+          <a:lstStyle xmlns:a="http://schemas.openxmlformats.org/drawingml/2006/main"/>
+          <a:p xmlns:a="http://schemas.openxmlformats.org/drawingml/2006/main"/>
+        </p:txBody>
+      </p:sp>
+    </p:spTree>
+  </p:cSld>
+  <p:clrMapOvr>
+    <a:masterClrMapping xmlns:a="http://schemas.openxmlformats.org/drawingml/2006/main"/>
+  </p:clrMapOvr>
+</p:notes>
+</file>
+
 <file path=ppt/notesSlides/notesSlide2.xml><?xml version="1.0" encoding="utf-8"?>
 <p:notes xmlns:p="http://schemas.openxmlformats.org/presentationml/2006/main">
   <p:cSld>
@@ -1599,7 +1670,7 @@
   </p:cSld>
   <p:clrMap bg1="lt1" tx1="dk1" bg2="lt2" tx2="dk2" accent1="accent1" accent2="accent2" accent3="accent3" accent4="accent4" accent5="accent5" accent6="accent6" hlink="hlink" folHlink="folHlink"/>
   <p:sldLayoutIdLst>
-    <p:sldLayoutId xmlns:r="http://schemas.openxmlformats.org/officeDocument/2006/relationships" id="2147483649" r:id="Re3bf0aaf8bc4499b"/>
+    <p:sldLayoutId xmlns:r="http://schemas.openxmlformats.org/officeDocument/2006/relationships" id="2147483649" r:id="Rfbac556d6ce24f42"/>
   </p:sldLayoutIdLst>
   <p:txStyles>
     <p:titleStyle>
@@ -2443,7 +2514,7 @@
           <p:nvPr/>
         </p:nvPicPr>
         <p:blipFill>
-          <a:blip xmlns:r="http://schemas.openxmlformats.org/officeDocument/2006/relationships" xmlns:a="http://schemas.openxmlformats.org/drawingml/2006/main" r:embed="R75cc990dd5f34969"/>
+          <a:blip xmlns:r="http://schemas.openxmlformats.org/officeDocument/2006/relationships" xmlns:a="http://schemas.openxmlformats.org/drawingml/2006/main" r:embed="Rfd75329a090a4039"/>
           <a:stretch xmlns:a="http://schemas.openxmlformats.org/drawingml/2006/main"/>
         </p:blipFill>
         <p:spPr>
@@ -2553,7 +2624,7 @@
                   <a:srgbClr val="526579"/>
                 </a:solidFill>
               </a:rPr>
-              <a:t>1 / 15</a:t>
+              <a:t>1 / 16</a:t>
             </a:r>
           </a:p>
         </p:txBody>
@@ -2848,7 +2919,7 @@
                   <a:srgbClr val="526579"/>
                 </a:solidFill>
               </a:rPr>
-              <a:t>10 / 15</a:t>
+              <a:t>10 / 16</a:t>
             </a:r>
           </a:p>
         </p:txBody>
@@ -4815,7 +4886,7 @@
                   <a:srgbClr val="526579"/>
                 </a:solidFill>
               </a:rPr>
-              <a:t>11 / 15</a:t>
+              <a:t>11 / 16</a:t>
             </a:r>
           </a:p>
         </p:txBody>
@@ -4893,7 +4964,7 @@
           <p:nvPr/>
         </p:nvPicPr>
         <p:blipFill>
-          <a:blip xmlns:r="http://schemas.openxmlformats.org/officeDocument/2006/relationships" xmlns:a="http://schemas.openxmlformats.org/drawingml/2006/main" r:embed="R31a6f73225f3439d"/>
+          <a:blip xmlns:r="http://schemas.openxmlformats.org/officeDocument/2006/relationships" xmlns:a="http://schemas.openxmlformats.org/drawingml/2006/main" r:embed="R305c7e250a204801"/>
           <a:stretch xmlns:a="http://schemas.openxmlformats.org/drawingml/2006/main"/>
         </p:blipFill>
         <p:spPr>
@@ -5484,7 +5555,7 @@
                   <a:srgbClr val="526579"/>
                 </a:solidFill>
               </a:rPr>
-              <a:t>12 / 15</a:t>
+              <a:t>12 / 16</a:t>
             </a:r>
           </a:p>
         </p:txBody>
@@ -6452,7 +6523,7 @@
                   <a:srgbClr val="526579"/>
                 </a:solidFill>
               </a:rPr>
-              <a:t>13 / 15</a:t>
+              <a:t>13 / 16</a:t>
             </a:r>
           </a:p>
         </p:txBody>
@@ -7458,7 +7529,7 @@
                   <a:srgbClr val="526579"/>
                 </a:solidFill>
               </a:rPr>
-              <a:t>14 / 15</a:t>
+              <a:t>14 / 16</a:t>
             </a:r>
           </a:p>
         </p:txBody>
@@ -8708,7 +8779,7 @@
                   <a:srgbClr val="526579"/>
                 </a:solidFill>
               </a:rPr>
-              <a:t>15 / 15</a:t>
+              <a:t>15 / 16</a:t>
             </a:r>
           </a:p>
         </p:txBody>
@@ -9379,6 +9450,479 @@
     <p:extLst>
       <p:ext uri="{BB962C8B-B14F-4D97-AF65-F5344CB8AC3E}">
         <p14:creationId xmlns:p14="http://schemas.microsoft.com/office/powerpoint/2010/main" val="1086182600"/>
+      </p:ext>
+    </p:extLst>
+  </p:cSld>
+</p:sld>
+</file>
+
+<file path=ppt/slides/slide16.xml><?xml version="1.0" encoding="utf-8"?>
+<p:sld xmlns:p="http://schemas.openxmlformats.org/presentationml/2006/main">
+  <p:cSld>
+    <p:bg>
+      <p:bgPr>
+        <a:solidFill xmlns:a="http://schemas.openxmlformats.org/drawingml/2006/main">
+          <a:srgbClr val="FFFFFF"/>
+        </a:solidFill>
+      </p:bgPr>
+    </p:bg>
+    <p:spTree>
+      <p:nvGrpSpPr>
+        <p:cNvPr id="1" name=""/>
+        <p:cNvGrpSpPr/>
+        <p:nvPr/>
+      </p:nvGrpSpPr>
+      <p:grpSpPr>
+        <a:xfrm xmlns:a="http://schemas.openxmlformats.org/drawingml/2006/main"/>
+      </p:grpSpPr>
+      <p:sp>
+        <p:nvSpPr>
+          <p:cNvPr id="10" name="">
+            <a:extLst xmlns:a="http://schemas.openxmlformats.org/drawingml/2006/main">
+              <a:ext uri="{FF2B5EF4-FFF2-40B4-BE49-F238E27FC236}">
+                <a16:creationId xmlns:a16="http://schemas.microsoft.com/office/drawing/2014/main" id="{3684153C-22E0-4E1C-8416-EBBE9C0B95EC}"/>
+              </a:ext>
+            </a:extLst>
+          </p:cNvPr>
+          <p:cNvSpPr>
+            <a:spLocks xmlns:a="http://schemas.openxmlformats.org/drawingml/2006/main" noGrp="1"/>
+          </p:cNvSpPr>
+          <p:nvPr/>
+        </p:nvSpPr>
+        <p:spPr>
+          <a:xfrm xmlns:a="http://schemas.openxmlformats.org/drawingml/2006/main">
+            <a:off x="0" y="0"/>
+            <a:ext cx="12192000" cy="76200"/>
+          </a:xfrm>
+          <a:prstGeom xmlns:a="http://schemas.openxmlformats.org/drawingml/2006/main" prst="rect">
+            <a:avLst/>
+          </a:prstGeom>
+          <a:solidFill xmlns:a="http://schemas.openxmlformats.org/drawingml/2006/main">
+            <a:srgbClr val="0F8B8D"/>
+          </a:solidFill>
+          <a:ln xmlns:a="http://schemas.openxmlformats.org/drawingml/2006/main" w="0">
+            <a:noFill/>
+            <a:prstDash val="solid"/>
+          </a:ln>
+        </p:spPr>
+      </p:sp>
+      <p:sp>
+        <p:nvSpPr>
+          <p:cNvPr id="2" name="">
+            <a:extLst xmlns:a="http://schemas.openxmlformats.org/drawingml/2006/main">
+              <a:ext uri="{FF2B5EF4-FFF2-40B4-BE49-F238E27FC236}">
+                <a16:creationId xmlns:a16="http://schemas.microsoft.com/office/drawing/2014/main" id="{7155C644-6622-496F-A7FC-A98AC223C335}"/>
+              </a:ext>
+            </a:extLst>
+          </p:cNvPr>
+          <p:cNvSpPr>
+            <a:spLocks xmlns:a="http://schemas.openxmlformats.org/drawingml/2006/main" noGrp="1"/>
+          </p:cNvSpPr>
+          <p:nvPr/>
+        </p:nvSpPr>
+        <p:spPr>
+          <a:xfrm xmlns:a="http://schemas.openxmlformats.org/drawingml/2006/main">
+            <a:off x="685800" y="1619250"/>
+            <a:ext cx="5905500" cy="266700"/>
+          </a:xfrm>
+          <a:prstGeom xmlns:a="http://schemas.openxmlformats.org/drawingml/2006/main" prst="rect">
+            <a:avLst/>
+          </a:prstGeom>
+          <a:noFill xmlns:a="http://schemas.openxmlformats.org/drawingml/2006/main"/>
+          <a:ln xmlns:a="http://schemas.openxmlformats.org/drawingml/2006/main" w="0">
+            <a:noFill/>
+            <a:prstDash val="solid"/>
+          </a:ln>
+        </p:spPr>
+        <p:txBody>
+          <a:bodyPr xmlns:a="http://schemas.openxmlformats.org/drawingml/2006/main"/>
+          <a:lstStyle xmlns:a="http://schemas.openxmlformats.org/drawingml/2006/main"/>
+          <a:p xmlns:a="http://schemas.openxmlformats.org/drawingml/2006/main">
+            <a:pPr algn="l">
+              <a:buNone/>
+              <a:defRPr sz="1275" b="1">
+                <a:solidFill>
+                  <a:srgbClr val="0F8B8D"/>
+                </a:solidFill>
+              </a:defRPr>
+            </a:pPr>
+            <a:r>
+              <a:rPr sz="1275" b="1">
+                <a:solidFill>
+                  <a:srgbClr val="0F8B8D"/>
+                </a:solidFill>
+              </a:rPr>
+              <a:t>HOẠT ĐỘNG CUỐI SEMINAR</a:t>
+            </a:r>
+          </a:p>
+        </p:txBody>
+      </p:sp>
+      <p:sp>
+        <p:nvSpPr>
+          <p:cNvPr id="3" name="">
+            <a:extLst xmlns:a="http://schemas.openxmlformats.org/drawingml/2006/main">
+              <a:ext uri="{FF2B5EF4-FFF2-40B4-BE49-F238E27FC236}">
+                <a16:creationId xmlns:a16="http://schemas.microsoft.com/office/drawing/2014/main" id="{5B8B074F-E560-4EBB-9C8E-4EFEB8A8673A}"/>
+              </a:ext>
+            </a:extLst>
+          </p:cNvPr>
+          <p:cNvSpPr>
+            <a:spLocks xmlns:a="http://schemas.openxmlformats.org/drawingml/2006/main" noGrp="1"/>
+          </p:cNvSpPr>
+          <p:nvPr/>
+        </p:nvSpPr>
+        <p:spPr>
+          <a:xfrm xmlns:a="http://schemas.openxmlformats.org/drawingml/2006/main">
+            <a:off x="685800" y="2038350"/>
+            <a:ext cx="6762750" cy="1428750"/>
+          </a:xfrm>
+          <a:prstGeom xmlns:a="http://schemas.openxmlformats.org/drawingml/2006/main" prst="rect">
+            <a:avLst/>
+          </a:prstGeom>
+          <a:noFill xmlns:a="http://schemas.openxmlformats.org/drawingml/2006/main"/>
+          <a:ln xmlns:a="http://schemas.openxmlformats.org/drawingml/2006/main" w="0">
+            <a:noFill/>
+            <a:prstDash val="solid"/>
+          </a:ln>
+        </p:spPr>
+        <p:txBody>
+          <a:bodyPr xmlns:a="http://schemas.openxmlformats.org/drawingml/2006/main"/>
+          <a:lstStyle xmlns:a="http://schemas.openxmlformats.org/drawingml/2006/main"/>
+          <a:p xmlns:a="http://schemas.openxmlformats.org/drawingml/2006/main">
+            <a:pPr algn="l">
+              <a:buNone/>
+              <a:defRPr sz="5100" b="1">
+                <a:solidFill>
+                  <a:srgbClr val="123B67"/>
+                </a:solidFill>
+              </a:defRPr>
+            </a:pPr>
+            <a:r>
+              <a:rPr sz="5100" b="1">
+                <a:solidFill>
+                  <a:srgbClr val="123B67"/>
+                </a:solidFill>
+              </a:rPr>
+              <a:t>Quét mã QR</a:t>
+            </a:r>
+          </a:p>
+          <a:p xmlns:a="http://schemas.openxmlformats.org/drawingml/2006/main">
+            <a:pPr algn="l">
+              <a:buNone/>
+              <a:defRPr sz="5100" b="1">
+                <a:solidFill>
+                  <a:srgbClr val="123B67"/>
+                </a:solidFill>
+              </a:defRPr>
+            </a:pPr>
+            <a:r>
+              <a:rPr sz="5100" b="1">
+                <a:solidFill>
+                  <a:srgbClr val="123B67"/>
+                </a:solidFill>
+              </a:rPr>
+              <a:t>để làm bài test</a:t>
+            </a:r>
+          </a:p>
+        </p:txBody>
+      </p:sp>
+      <p:sp>
+        <p:nvSpPr>
+          <p:cNvPr id="4" name="">
+            <a:extLst xmlns:a="http://schemas.openxmlformats.org/drawingml/2006/main">
+              <a:ext uri="{FF2B5EF4-FFF2-40B4-BE49-F238E27FC236}">
+                <a16:creationId xmlns:a16="http://schemas.microsoft.com/office/drawing/2014/main" id="{F1D41BE3-9558-493F-93C1-80AB81D87D4B}"/>
+              </a:ext>
+            </a:extLst>
+          </p:cNvPr>
+          <p:cNvSpPr>
+            <a:spLocks xmlns:a="http://schemas.openxmlformats.org/drawingml/2006/main" noGrp="1"/>
+          </p:cNvSpPr>
+          <p:nvPr/>
+        </p:nvSpPr>
+        <p:spPr>
+          <a:xfrm xmlns:a="http://schemas.openxmlformats.org/drawingml/2006/main">
+            <a:off x="685800" y="3581400"/>
+            <a:ext cx="7143750" cy="876300"/>
+          </a:xfrm>
+          <a:prstGeom xmlns:a="http://schemas.openxmlformats.org/drawingml/2006/main" prst="rect">
+            <a:avLst/>
+          </a:prstGeom>
+          <a:noFill xmlns:a="http://schemas.openxmlformats.org/drawingml/2006/main"/>
+          <a:ln xmlns:a="http://schemas.openxmlformats.org/drawingml/2006/main" w="0">
+            <a:noFill/>
+            <a:prstDash val="solid"/>
+          </a:ln>
+        </p:spPr>
+        <p:txBody>
+          <a:bodyPr xmlns:a="http://schemas.openxmlformats.org/drawingml/2006/main"/>
+          <a:lstStyle xmlns:a="http://schemas.openxmlformats.org/drawingml/2006/main"/>
+          <a:p xmlns:a="http://schemas.openxmlformats.org/drawingml/2006/main">
+            <a:pPr algn="l">
+              <a:buNone/>
+              <a:defRPr sz="1950" b="0">
+                <a:solidFill>
+                  <a:srgbClr val="526579"/>
+                </a:solidFill>
+              </a:defRPr>
+            </a:pPr>
+            <a:r>
+              <a:rPr sz="1950" b="0">
+                <a:solidFill>
+                  <a:srgbClr val="526579"/>
+                </a:solidFill>
+              </a:rPr>
+              <a:t>Dùng điện thoại quét mã để mở bài test về database testing, DbUnit, Database Rider và Tonic.ai.</a:t>
+            </a:r>
+          </a:p>
+        </p:txBody>
+      </p:sp>
+      <p:sp>
+        <p:nvSpPr>
+          <p:cNvPr id="5" name="">
+            <a:extLst xmlns:a="http://schemas.openxmlformats.org/drawingml/2006/main">
+              <a:ext uri="{FF2B5EF4-FFF2-40B4-BE49-F238E27FC236}">
+                <a16:creationId xmlns:a16="http://schemas.microsoft.com/office/drawing/2014/main" id="{0DFE96B1-A0A8-4F52-86B0-5E199F593B09}"/>
+              </a:ext>
+            </a:extLst>
+          </p:cNvPr>
+          <p:cNvSpPr>
+            <a:spLocks xmlns:a="http://schemas.openxmlformats.org/drawingml/2006/main" noGrp="1"/>
+          </p:cNvSpPr>
+          <p:nvPr/>
+        </p:nvSpPr>
+        <p:spPr>
+          <a:xfrm xmlns:a="http://schemas.openxmlformats.org/drawingml/2006/main">
+            <a:off x="685800" y="4686300"/>
+            <a:ext cx="4953000" cy="914400"/>
+          </a:xfrm>
+          <a:prstGeom xmlns:a="http://schemas.openxmlformats.org/drawingml/2006/main" prst="rect">
+            <a:avLst/>
+          </a:prstGeom>
+          <a:noFill xmlns:a="http://schemas.openxmlformats.org/drawingml/2006/main"/>
+          <a:ln xmlns:a="http://schemas.openxmlformats.org/drawingml/2006/main" w="0">
+            <a:noFill/>
+            <a:prstDash val="solid"/>
+          </a:ln>
+        </p:spPr>
+        <p:txBody>
+          <a:bodyPr xmlns:a="http://schemas.openxmlformats.org/drawingml/2006/main"/>
+          <a:lstStyle xmlns:a="http://schemas.openxmlformats.org/drawingml/2006/main"/>
+          <a:p xmlns:a="http://schemas.openxmlformats.org/drawingml/2006/main">
+            <a:pPr algn="l">
+              <a:buNone/>
+              <a:defRPr sz="1350" b="0">
+                <a:solidFill>
+                  <a:srgbClr val="526579"/>
+                </a:solidFill>
+              </a:defRPr>
+            </a:pPr>
+            <a:r>
+              <a:rPr sz="1350" b="0">
+                <a:solidFill>
+                  <a:srgbClr val="526579"/>
+                </a:solidFill>
+              </a:rPr>
+              <a:t>Chúc các bạn hoàn thành tốt!</a:t>
+            </a:r>
+          </a:p>
+          <a:p xmlns:a="http://schemas.openxmlformats.org/drawingml/2006/main">
+            <a:pPr algn="l">
+              <a:buNone/>
+              <a:defRPr sz="1350" b="0">
+                <a:solidFill>
+                  <a:srgbClr val="526579"/>
+                </a:solidFill>
+              </a:defRPr>
+            </a:pPr>
+            <a:r>
+              <a:rPr sz="1350" b="0">
+                <a:solidFill>
+                  <a:srgbClr val="526579"/>
+                </a:solidFill>
+              </a:rPr>
+              <a:t>Cảm ơn thầy và các bạn đã tham gia.</a:t>
+            </a:r>
+          </a:p>
+          <a:p xmlns:a="http://schemas.openxmlformats.org/drawingml/2006/main">
+            <a:pPr algn="l">
+              <a:buNone/>
+              <a:defRPr sz="1350" b="0">
+                <a:solidFill>
+                  <a:srgbClr val="526579"/>
+                </a:solidFill>
+              </a:defRPr>
+            </a:pPr>
+            <a:r>
+              <a:rPr sz="1350" b="0">
+                <a:solidFill>
+                  <a:srgbClr val="526579"/>
+                </a:solidFill>
+              </a:rPr>
+              <a:t> </a:t>
+            </a:r>
+          </a:p>
+        </p:txBody>
+      </p:sp>
+      <p:sp>
+        <p:nvSpPr>
+          <p:cNvPr id="7" name="">
+            <a:extLst xmlns:a="http://schemas.openxmlformats.org/drawingml/2006/main">
+              <a:ext uri="{FF2B5EF4-FFF2-40B4-BE49-F238E27FC236}">
+                <a16:creationId xmlns:a16="http://schemas.microsoft.com/office/drawing/2014/main" id="{13ECE4E8-539E-4ACA-A6EF-852D9C75867C}"/>
+              </a:ext>
+            </a:extLst>
+          </p:cNvPr>
+          <p:cNvSpPr>
+            <a:spLocks xmlns:a="http://schemas.openxmlformats.org/drawingml/2006/main" noGrp="1"/>
+          </p:cNvSpPr>
+          <p:nvPr/>
+        </p:nvSpPr>
+        <p:spPr>
+          <a:xfrm xmlns:a="http://schemas.openxmlformats.org/drawingml/2006/main">
+            <a:off x="685800" y="6477000"/>
+            <a:ext cx="2476500" cy="190500"/>
+          </a:xfrm>
+          <a:prstGeom xmlns:a="http://schemas.openxmlformats.org/drawingml/2006/main" prst="rect">
+            <a:avLst/>
+          </a:prstGeom>
+          <a:noFill xmlns:a="http://schemas.openxmlformats.org/drawingml/2006/main"/>
+          <a:ln xmlns:a="http://schemas.openxmlformats.org/drawingml/2006/main" w="0">
+            <a:noFill/>
+            <a:prstDash val="solid"/>
+          </a:ln>
+        </p:spPr>
+        <p:txBody>
+          <a:bodyPr xmlns:a="http://schemas.openxmlformats.org/drawingml/2006/main"/>
+          <a:lstStyle xmlns:a="http://schemas.openxmlformats.org/drawingml/2006/main"/>
+          <a:p xmlns:a="http://schemas.openxmlformats.org/drawingml/2006/main">
+            <a:pPr algn="l">
+              <a:buNone/>
+              <a:defRPr sz="1050" b="0">
+                <a:solidFill>
+                  <a:srgbClr val="526579"/>
+                </a:solidFill>
+              </a:defRPr>
+            </a:pPr>
+            <a:r>
+              <a:rPr sz="1050" b="0">
+                <a:solidFill>
+                  <a:srgbClr val="526579"/>
+                </a:solidFill>
+              </a:rPr>
+              <a:t>ĐHQG-HCM - KHTN</a:t>
+            </a:r>
+          </a:p>
+        </p:txBody>
+      </p:sp>
+      <p:sp>
+        <p:nvSpPr>
+          <p:cNvPr id="8" name="">
+            <a:extLst xmlns:a="http://schemas.openxmlformats.org/drawingml/2006/main">
+              <a:ext uri="{FF2B5EF4-FFF2-40B4-BE49-F238E27FC236}">
+                <a16:creationId xmlns:a16="http://schemas.microsoft.com/office/drawing/2014/main" id="{7211B0E2-DB9E-45ED-ACC2-7B88057905F8}"/>
+              </a:ext>
+            </a:extLst>
+          </p:cNvPr>
+          <p:cNvSpPr>
+            <a:spLocks xmlns:a="http://schemas.openxmlformats.org/drawingml/2006/main" noGrp="1"/>
+          </p:cNvSpPr>
+          <p:nvPr/>
+        </p:nvSpPr>
+        <p:spPr>
+          <a:xfrm xmlns:a="http://schemas.openxmlformats.org/drawingml/2006/main">
+            <a:off x="9667875" y="6477000"/>
+            <a:ext cx="952500" cy="190500"/>
+          </a:xfrm>
+          <a:prstGeom xmlns:a="http://schemas.openxmlformats.org/drawingml/2006/main" prst="rect">
+            <a:avLst/>
+          </a:prstGeom>
+          <a:noFill xmlns:a="http://schemas.openxmlformats.org/drawingml/2006/main"/>
+          <a:ln xmlns:a="http://schemas.openxmlformats.org/drawingml/2006/main" w="0">
+            <a:noFill/>
+            <a:prstDash val="solid"/>
+          </a:ln>
+        </p:spPr>
+        <p:txBody>
+          <a:bodyPr xmlns:a="http://schemas.openxmlformats.org/drawingml/2006/main"/>
+          <a:lstStyle xmlns:a="http://schemas.openxmlformats.org/drawingml/2006/main"/>
+          <a:p xmlns:a="http://schemas.openxmlformats.org/drawingml/2006/main">
+            <a:pPr algn="r">
+              <a:buNone/>
+              <a:defRPr sz="1050" b="0">
+                <a:solidFill>
+                  <a:srgbClr val="526579"/>
+                </a:solidFill>
+              </a:defRPr>
+            </a:pPr>
+            <a:r>
+              <a:rPr sz="1050" b="0">
+                <a:solidFill>
+                  <a:srgbClr val="526579"/>
+                </a:solidFill>
+              </a:rPr>
+              <a:t>16 / 16</a:t>
+            </a:r>
+          </a:p>
+        </p:txBody>
+      </p:sp>
+      <p:sp>
+        <p:nvSpPr>
+          <p:cNvPr id="9" name="">
+            <a:extLst xmlns:a="http://schemas.openxmlformats.org/drawingml/2006/main">
+              <a:ext uri="{FF2B5EF4-FFF2-40B4-BE49-F238E27FC236}">
+                <a16:creationId xmlns:a16="http://schemas.microsoft.com/office/drawing/2014/main" id="{3192AAE9-323E-4CE4-B1B1-EB1282CBECE9}"/>
+              </a:ext>
+            </a:extLst>
+          </p:cNvPr>
+          <p:cNvSpPr>
+            <a:spLocks xmlns:a="http://schemas.openxmlformats.org/drawingml/2006/main" noGrp="1"/>
+          </p:cNvSpPr>
+          <p:nvPr/>
+        </p:nvSpPr>
+        <p:spPr>
+          <a:xfrm xmlns:a="http://schemas.openxmlformats.org/drawingml/2006/main">
+            <a:off x="0" y="6810375"/>
+            <a:ext cx="933450" cy="47625"/>
+          </a:xfrm>
+          <a:prstGeom xmlns:a="http://schemas.openxmlformats.org/drawingml/2006/main" prst="rect">
+            <a:avLst/>
+          </a:prstGeom>
+          <a:solidFill xmlns:a="http://schemas.openxmlformats.org/drawingml/2006/main">
+            <a:srgbClr val="0F8B8D"/>
+          </a:solidFill>
+          <a:ln xmlns:a="http://schemas.openxmlformats.org/drawingml/2006/main" w="0">
+            <a:noFill/>
+            <a:prstDash val="solid"/>
+          </a:ln>
+        </p:spPr>
+      </p:sp>
+      <p:pic>
+        <p:nvPicPr>
+          <p:cNvPr id="20" name=""/>
+          <p:cNvPicPr>
+            <a:picLocks xmlns:a="http://schemas.openxmlformats.org/drawingml/2006/main" noChangeAspect="1"/>
+          </p:cNvPicPr>
+          <p:nvPr/>
+        </p:nvPicPr>
+        <p:blipFill>
+          <a:blip xmlns:r="http://schemas.openxmlformats.org/officeDocument/2006/relationships" xmlns:a="http://schemas.openxmlformats.org/drawingml/2006/main" r:embed="R26d73286da024bbf"/>
+          <a:stretch xmlns:a="http://schemas.openxmlformats.org/drawingml/2006/main"/>
+        </p:blipFill>
+        <p:spPr>
+          <a:xfrm xmlns:a="http://schemas.openxmlformats.org/drawingml/2006/main">
+            <a:off x="8477250" y="2095500"/>
+            <a:ext cx="2857500" cy="2857500"/>
+          </a:xfrm>
+          <a:prstGeom xmlns:a="http://schemas.openxmlformats.org/drawingml/2006/main" prst="rect">
+            <a:avLst/>
+          </a:prstGeom>
+        </p:spPr>
+      </p:pic>
+    </p:spTree>
+    <p:extLst>
+      <p:ext uri="{BB962C8B-B14F-4D97-AF65-F5344CB8AC3E}">
+        <p14:creationId xmlns:p14="http://schemas.microsoft.com/office/powerpoint/2010/main" val="888573123"/>
       </p:ext>
     </p:extLst>
   </p:cSld>
@@ -9634,7 +10178,7 @@
                   <a:srgbClr val="526579"/>
                 </a:solidFill>
               </a:rPr>
-              <a:t>2 / 15</a:t>
+              <a:t>2 / 16</a:t>
             </a:r>
           </a:p>
         </p:txBody>
@@ -10509,7 +11053,7 @@
                   <a:srgbClr val="526579"/>
                 </a:solidFill>
               </a:rPr>
-              <a:t>3 / 15</a:t>
+              <a:t>3 / 16</a:t>
             </a:r>
           </a:p>
         </p:txBody>
@@ -12476,7 +13020,7 @@
                   <a:srgbClr val="526579"/>
                 </a:solidFill>
               </a:rPr>
-              <a:t>4 / 15</a:t>
+              <a:t>4 / 16</a:t>
             </a:r>
           </a:p>
         </p:txBody>
@@ -13935,7 +14479,7 @@
                   <a:srgbClr val="526579"/>
                 </a:solidFill>
               </a:rPr>
-              <a:t>5 / 15</a:t>
+              <a:t>5 / 16</a:t>
             </a:r>
           </a:p>
         </p:txBody>
@@ -14977,7 +15521,7 @@
                   <a:srgbClr val="526579"/>
                 </a:solidFill>
               </a:rPr>
-              <a:t>6 / 15</a:t>
+              <a:t>6 / 16</a:t>
             </a:r>
           </a:p>
         </p:txBody>
@@ -16749,7 +17293,7 @@
                   <a:srgbClr val="526579"/>
                 </a:solidFill>
               </a:rPr>
-              <a:t>7 / 15</a:t>
+              <a:t>7 / 16</a:t>
             </a:r>
           </a:p>
         </p:txBody>
@@ -16827,7 +17371,7 @@
           <p:nvPr/>
         </p:nvPicPr>
         <p:blipFill>
-          <a:blip xmlns:r="http://schemas.openxmlformats.org/officeDocument/2006/relationships" xmlns:a="http://schemas.openxmlformats.org/drawingml/2006/main" r:embed="Reaa64d6b904e405e"/>
+          <a:blip xmlns:r="http://schemas.openxmlformats.org/officeDocument/2006/relationships" xmlns:a="http://schemas.openxmlformats.org/drawingml/2006/main" r:embed="R1e20a7b72f8142b3"/>
           <a:stretch xmlns:a="http://schemas.openxmlformats.org/drawingml/2006/main"/>
         </p:blipFill>
         <p:spPr>
@@ -17814,7 +18358,7 @@
                   <a:srgbClr val="526579"/>
                 </a:solidFill>
               </a:rPr>
-              <a:t>8 / 15</a:t>
+              <a:t>8 / 16</a:t>
             </a:r>
           </a:p>
         </p:txBody>
@@ -17892,7 +18436,7 @@
           <p:nvPr/>
         </p:nvPicPr>
         <p:blipFill>
-          <a:blip xmlns:r="http://schemas.openxmlformats.org/officeDocument/2006/relationships" xmlns:a="http://schemas.openxmlformats.org/drawingml/2006/main" r:embed="R56f2e688d8e34e5f"/>
+          <a:blip xmlns:r="http://schemas.openxmlformats.org/officeDocument/2006/relationships" xmlns:a="http://schemas.openxmlformats.org/drawingml/2006/main" r:embed="R658c3d8fc61d451e"/>
           <a:stretch xmlns:a="http://schemas.openxmlformats.org/drawingml/2006/main"/>
         </p:blipFill>
         <p:spPr>
@@ -18418,7 +18962,7 @@
                   <a:srgbClr val="526579"/>
                 </a:solidFill>
               </a:rPr>
-              <a:t>9 / 15</a:t>
+              <a:t>9 / 16</a:t>
             </a:r>
           </a:p>
         </p:txBody>
@@ -18496,7 +19040,7 @@
           <p:nvPr/>
         </p:nvPicPr>
         <p:blipFill>
-          <a:blip xmlns:r="http://schemas.openxmlformats.org/officeDocument/2006/relationships" xmlns:a="http://schemas.openxmlformats.org/drawingml/2006/main" r:embed="R55814a69a8d94c2c"/>
+          <a:blip xmlns:r="http://schemas.openxmlformats.org/officeDocument/2006/relationships" xmlns:a="http://schemas.openxmlformats.org/drawingml/2006/main" r:embed="R5f01b31fc3ef4598"/>
           <a:stretch xmlns:a="http://schemas.openxmlformats.org/drawingml/2006/main"/>
         </p:blipFill>
         <p:spPr>

</xml_diff>